<commit_message>
analysis plots, konza fire, and si
</commit_message>
<xml_diff>
--- a/Figs/Conceptual Figure/conceptual model.pptx
+++ b/Figs/Conceptual Figure/conceptual model.pptx
@@ -199,7 +199,7 @@
           <a:p>
             <a:fld id="{78EDAD2D-3B8D-CA44-87F6-841385491A37}" type="datetimeFigureOut">
               <a:rPr lang="en-US" smtClean="0"/>
-              <a:t>4/8/26</a:t>
+              <a:t>8/14/26</a:t>
             </a:fld>
             <a:endParaRPr lang="en-US"/>
           </a:p>
@@ -1059,7 +1059,7 @@
           <a:p>
             <a:fld id="{942A2C66-2889-E643-BF10-6F4E9B1D3607}" type="datetimeFigureOut">
               <a:rPr lang="en-US" smtClean="0"/>
-              <a:t>4/8/26</a:t>
+              <a:t>8/14/26</a:t>
             </a:fld>
             <a:endParaRPr lang="en-US"/>
           </a:p>
@@ -1257,7 +1257,7 @@
           <a:p>
             <a:fld id="{942A2C66-2889-E643-BF10-6F4E9B1D3607}" type="datetimeFigureOut">
               <a:rPr lang="en-US" smtClean="0"/>
-              <a:t>4/8/26</a:t>
+              <a:t>8/14/26</a:t>
             </a:fld>
             <a:endParaRPr lang="en-US"/>
           </a:p>
@@ -1465,7 +1465,7 @@
           <a:p>
             <a:fld id="{942A2C66-2889-E643-BF10-6F4E9B1D3607}" type="datetimeFigureOut">
               <a:rPr lang="en-US" smtClean="0"/>
-              <a:t>4/8/26</a:t>
+              <a:t>8/14/26</a:t>
             </a:fld>
             <a:endParaRPr lang="en-US"/>
           </a:p>
@@ -1663,7 +1663,7 @@
           <a:p>
             <a:fld id="{942A2C66-2889-E643-BF10-6F4E9B1D3607}" type="datetimeFigureOut">
               <a:rPr lang="en-US" smtClean="0"/>
-              <a:t>4/8/26</a:t>
+              <a:t>8/14/26</a:t>
             </a:fld>
             <a:endParaRPr lang="en-US"/>
           </a:p>
@@ -1938,7 +1938,7 @@
           <a:p>
             <a:fld id="{942A2C66-2889-E643-BF10-6F4E9B1D3607}" type="datetimeFigureOut">
               <a:rPr lang="en-US" smtClean="0"/>
-              <a:t>4/8/26</a:t>
+              <a:t>8/14/26</a:t>
             </a:fld>
             <a:endParaRPr lang="en-US"/>
           </a:p>
@@ -2203,7 +2203,7 @@
           <a:p>
             <a:fld id="{942A2C66-2889-E643-BF10-6F4E9B1D3607}" type="datetimeFigureOut">
               <a:rPr lang="en-US" smtClean="0"/>
-              <a:t>4/8/26</a:t>
+              <a:t>8/14/26</a:t>
             </a:fld>
             <a:endParaRPr lang="en-US"/>
           </a:p>
@@ -2615,7 +2615,7 @@
           <a:p>
             <a:fld id="{942A2C66-2889-E643-BF10-6F4E9B1D3607}" type="datetimeFigureOut">
               <a:rPr lang="en-US" smtClean="0"/>
-              <a:t>4/8/26</a:t>
+              <a:t>8/14/26</a:t>
             </a:fld>
             <a:endParaRPr lang="en-US"/>
           </a:p>
@@ -2756,7 +2756,7 @@
           <a:p>
             <a:fld id="{942A2C66-2889-E643-BF10-6F4E9B1D3607}" type="datetimeFigureOut">
               <a:rPr lang="en-US" smtClean="0"/>
-              <a:t>4/8/26</a:t>
+              <a:t>8/14/26</a:t>
             </a:fld>
             <a:endParaRPr lang="en-US"/>
           </a:p>
@@ -2869,7 +2869,7 @@
           <a:p>
             <a:fld id="{942A2C66-2889-E643-BF10-6F4E9B1D3607}" type="datetimeFigureOut">
               <a:rPr lang="en-US" smtClean="0"/>
-              <a:t>4/8/26</a:t>
+              <a:t>8/14/26</a:t>
             </a:fld>
             <a:endParaRPr lang="en-US"/>
           </a:p>
@@ -3180,7 +3180,7 @@
           <a:p>
             <a:fld id="{942A2C66-2889-E643-BF10-6F4E9B1D3607}" type="datetimeFigureOut">
               <a:rPr lang="en-US" smtClean="0"/>
-              <a:t>4/8/26</a:t>
+              <a:t>8/14/26</a:t>
             </a:fld>
             <a:endParaRPr lang="en-US"/>
           </a:p>
@@ -3468,7 +3468,7 @@
           <a:p>
             <a:fld id="{942A2C66-2889-E643-BF10-6F4E9B1D3607}" type="datetimeFigureOut">
               <a:rPr lang="en-US" smtClean="0"/>
-              <a:t>4/8/26</a:t>
+              <a:t>8/14/26</a:t>
             </a:fld>
             <a:endParaRPr lang="en-US"/>
           </a:p>
@@ -3709,7 +3709,7 @@
           <a:p>
             <a:fld id="{942A2C66-2889-E643-BF10-6F4E9B1D3607}" type="datetimeFigureOut">
               <a:rPr lang="en-US" smtClean="0"/>
-              <a:t>4/8/26</a:t>
+              <a:t>8/14/26</a:t>
             </a:fld>
             <a:endParaRPr lang="en-US"/>
           </a:p>
@@ -10376,10 +10376,10 @@
           </p:nvGrpSpPr>
           <p:grpSpPr>
             <a:xfrm>
-              <a:off x="869211" y="3853505"/>
-              <a:ext cx="1156804" cy="1164759"/>
-              <a:chOff x="5921703" y="17361"/>
-              <a:chExt cx="738110" cy="743185"/>
+              <a:off x="896791" y="3853505"/>
+              <a:ext cx="1129227" cy="1164759"/>
+              <a:chOff x="5939299" y="17361"/>
+              <a:chExt cx="720514" cy="743185"/>
             </a:xfrm>
           </p:grpSpPr>
           <p:grpSp>
@@ -10396,10 +10396,10 @@
             </p:nvGrpSpPr>
             <p:grpSpPr>
               <a:xfrm>
-                <a:off x="5921703" y="17361"/>
-                <a:ext cx="531905" cy="626150"/>
-                <a:chOff x="2871655" y="1066533"/>
-                <a:chExt cx="531905" cy="626150"/>
+                <a:off x="5939299" y="17361"/>
+                <a:ext cx="514309" cy="626150"/>
+                <a:chOff x="2889251" y="1066533"/>
+                <a:chExt cx="514309" cy="626150"/>
               </a:xfrm>
             </p:grpSpPr>
             <p:grpSp>
@@ -10659,8 +10659,8 @@
               </p:nvSpPr>
               <p:spPr>
                 <a:xfrm rot="16200000">
-                  <a:off x="2657435" y="1280753"/>
-                  <a:ext cx="601097" cy="172658"/>
+                  <a:off x="2657435" y="1298349"/>
+                  <a:ext cx="601097" cy="137466"/>
                 </a:xfrm>
                 <a:prstGeom prst="rect">
                   <a:avLst/>
@@ -10736,7 +10736,7 @@
           <p:spPr>
             <a:xfrm>
               <a:off x="1968327" y="2640796"/>
-              <a:ext cx="999636" cy="502536"/>
+              <a:ext cx="999636" cy="400110"/>
             </a:xfrm>
             <a:prstGeom prst="rect">
               <a:avLst/>
@@ -10783,7 +10783,7 @@
           <p:spPr>
             <a:xfrm>
               <a:off x="1218556" y="2646300"/>
-              <a:ext cx="1004318" cy="502536"/>
+              <a:ext cx="1004318" cy="400110"/>
             </a:xfrm>
             <a:prstGeom prst="rect">
               <a:avLst/>
@@ -10830,7 +10830,7 @@
           <p:spPr>
             <a:xfrm>
               <a:off x="1983546" y="2714002"/>
-              <a:ext cx="372328" cy="309253"/>
+              <a:ext cx="372328" cy="246221"/>
             </a:xfrm>
             <a:prstGeom prst="rect">
               <a:avLst/>
@@ -10866,10 +10866,10 @@
           </p:nvGrpSpPr>
           <p:grpSpPr>
             <a:xfrm>
-              <a:off x="4328043" y="2703515"/>
-              <a:ext cx="2052479" cy="502540"/>
+              <a:off x="4328043" y="2703512"/>
+              <a:ext cx="2052479" cy="408738"/>
               <a:chOff x="3886300" y="2565299"/>
-              <a:chExt cx="1031780" cy="320650"/>
+              <a:chExt cx="1031780" cy="260799"/>
             </a:xfrm>
           </p:grpSpPr>
           <p:sp>
@@ -10887,7 +10887,7 @@
             <p:spPr>
               <a:xfrm>
                 <a:off x="4340958" y="2565299"/>
-                <a:ext cx="577122" cy="320650"/>
+                <a:ext cx="577122" cy="255294"/>
               </a:xfrm>
               <a:prstGeom prst="rect">
                 <a:avLst/>
@@ -10981,7 +10981,7 @@
             <p:spPr>
               <a:xfrm>
                 <a:off x="4377799" y="2644654"/>
-                <a:ext cx="59522" cy="160325"/>
+                <a:ext cx="59522" cy="127647"/>
               </a:xfrm>
               <a:prstGeom prst="rect">
                 <a:avLst/>
@@ -11018,10 +11018,10 @@
           </p:nvGrpSpPr>
           <p:grpSpPr>
             <a:xfrm>
-              <a:off x="7686722" y="2748158"/>
-              <a:ext cx="2212640" cy="505229"/>
+              <a:off x="7686722" y="2748162"/>
+              <a:ext cx="2212640" cy="402800"/>
               <a:chOff x="5969159" y="2575939"/>
-              <a:chExt cx="1411796" cy="322366"/>
+              <a:chExt cx="1411796" cy="257010"/>
             </a:xfrm>
           </p:grpSpPr>
           <p:sp>
@@ -11039,7 +11039,7 @@
             <p:spPr>
               <a:xfrm>
                 <a:off x="6233486" y="2577655"/>
-                <a:ext cx="1147469" cy="320650"/>
+                <a:ext cx="1147469" cy="255294"/>
               </a:xfrm>
               <a:prstGeom prst="rect">
                 <a:avLst/>
@@ -11133,7 +11133,7 @@
             <p:spPr>
               <a:xfrm>
                 <a:off x="6455539" y="2644806"/>
-                <a:ext cx="236086" cy="160325"/>
+                <a:ext cx="236086" cy="127647"/>
               </a:xfrm>
               <a:prstGeom prst="rect">
                 <a:avLst/>
@@ -11211,8 +11211,9 @@
                   <a:solidFill>
                     <a:sysClr val="windowText" lastClr="000000"/>
                   </a:solidFill>
+                  <a:latin typeface="Helvetica" pitchFamily="2" charset="0"/>
                 </a:rPr>
-                <a:t>State 1: Oxygenated</a:t>
+                <a:t>Oxygenated State</a:t>
               </a:r>
             </a:p>
           </p:txBody>
@@ -11272,8 +11273,9 @@
                   <a:solidFill>
                     <a:schemeClr val="tx1"/>
                   </a:solidFill>
+                  <a:latin typeface="Helvetica" pitchFamily="2" charset="0"/>
                 </a:rPr>
-                <a:t>State 2: Transitional</a:t>
+                <a:t>Transitional State</a:t>
               </a:r>
             </a:p>
           </p:txBody>
@@ -11331,8 +11333,9 @@
                   <a:solidFill>
                     <a:schemeClr val="tx1"/>
                   </a:solidFill>
+                  <a:latin typeface="Helvetica" pitchFamily="2" charset="0"/>
                 </a:rPr>
-                <a:t>State 3: Hypoxic</a:t>
+                <a:t>Hypoxic State</a:t>
               </a:r>
             </a:p>
           </p:txBody>
@@ -11630,7 +11633,7 @@
           <p:spPr>
             <a:xfrm>
               <a:off x="4514506" y="5013111"/>
-              <a:ext cx="1700915" cy="369332"/>
+              <a:ext cx="1749197" cy="369332"/>
             </a:xfrm>
             <a:prstGeom prst="rect">
               <a:avLst/>
@@ -11644,7 +11647,9 @@
             <a:lstStyle/>
             <a:p>
               <a:r>
-                <a:rPr lang="en-US" dirty="0"/>
+                <a:rPr lang="en-US" dirty="0">
+                  <a:latin typeface="Helvetica" pitchFamily="2" charset="0"/>
+                </a:rPr>
                 <a:t>Network Extent</a:t>
               </a:r>
             </a:p>
@@ -11665,7 +11670,7 @@
           <p:spPr>
             <a:xfrm>
               <a:off x="764184" y="5011951"/>
-              <a:ext cx="308098" cy="369332"/>
+              <a:ext cx="319318" cy="369332"/>
             </a:xfrm>
             <a:prstGeom prst="rect">
               <a:avLst/>
@@ -11679,7 +11684,9 @@
             <a:lstStyle/>
             <a:p>
               <a:r>
-                <a:rPr lang="en-US" dirty="0"/>
+                <a:rPr lang="en-US" dirty="0">
+                  <a:latin typeface="Helvetica" pitchFamily="2" charset="0"/>
+                </a:rPr>
                 <a:t>+</a:t>
               </a:r>
             </a:p>
@@ -11714,7 +11721,9 @@
             <a:lstStyle/>
             <a:p>
               <a:r>
-                <a:rPr lang="en-US" dirty="0"/>
+                <a:rPr lang="en-US" dirty="0">
+                  <a:latin typeface="Helvetica" pitchFamily="2" charset="0"/>
+                </a:rPr>
                 <a:t>-</a:t>
               </a:r>
             </a:p>
@@ -11734,10 +11743,10 @@
           </p:nvGrpSpPr>
           <p:grpSpPr>
             <a:xfrm>
-              <a:off x="4648041" y="3856957"/>
-              <a:ext cx="1156805" cy="1164758"/>
-              <a:chOff x="3305038" y="5544847"/>
-              <a:chExt cx="1156805" cy="1164758"/>
+              <a:off x="4675619" y="3856956"/>
+              <a:ext cx="1129227" cy="1164759"/>
+              <a:chOff x="3332616" y="5544846"/>
+              <a:chExt cx="1129227" cy="1164759"/>
             </a:xfrm>
           </p:grpSpPr>
           <p:sp>
@@ -11754,8 +11763,8 @@
             </p:nvSpPr>
             <p:spPr>
               <a:xfrm rot="16200000">
-                <a:off x="2969302" y="5880583"/>
-                <a:ext cx="942072" cy="270599"/>
+                <a:off x="2969302" y="5908160"/>
+                <a:ext cx="942072" cy="215444"/>
               </a:xfrm>
               <a:prstGeom prst="rect">
                 <a:avLst/>

</xml_diff>